<commit_message>
docs: give each member a separate script section and drop the one-line round-robin
Slide 9 is now Charith's operations and quality part. The script PDF lists
who does what, then each member's exact words in their own section.

Co-Authored-By: Claude Sonnet 5.5 <noreply@anthropic.com>
</commit_message>
<xml_diff>
--- a/deliverables/REOAGMS-Team-Presentation.pptx
+++ b/deliverables/REOAGMS-Team-Presentation.pptx
@@ -599,7 +599,7 @@
           <a:p>
             <a:r>
               <a:rPr lang="en-US" dirty="0"/>
-              <a:t>All members (4:50–5:00): ALL: Thank you. We are happy to take your questions.</a:t>
+              <a:t>All members (4:50–5:00): Thank you. We are happy to take your questions.</a:t>
             </a:r>
             <a:endParaRPr lang="en-US" dirty="0"/>
           </a:p>
@@ -1303,7 +1303,7 @@
           <a:p>
             <a:r>
               <a:rPr lang="en-US" dirty="0"/>
-              <a:t>All members (4:15–4:50): CHARITH: Operations are visible in Grafana, where Prometheus scrapes all seven services. NEMAL: Validation and tests protect every API. GOVINDU: Rules are data, so thresholds change without code. THURUNU: Every fault ends as recorded maintenance. YASIRU: Every notification is stored and can be retried. SACHINTHANA: Reports turn operations into decisions.</a:t>
+              <a:t>Charith (4:15–4:50): Operations are visible in Grafana, where Prometheus scrapes all seven services and shows platform health. Behind the demo are sixty test methods, validation and error handling in every service, and a versioned event contract that keeps the services compatible. The whole system starts with one docker compose command.</a:t>
             </a:r>
             <a:endParaRPr lang="en-US" dirty="0"/>
           </a:p>
@@ -9370,7 +9370,7 @@
                 <a:ea typeface="Segoe UI Semibold" pitchFamily="34" charset="-122"/>
                 <a:cs typeface="Segoe UI Semibold" pitchFamily="34" charset="-120"/>
               </a:rPr>
-              <a:t>09 · ALL MEMBERS · OPERATIONS AND QUALITY</a:t>
+              <a:t>09 · CHARITH · OPERATIONS AND QUALITY</a:t>
             </a:r>
             <a:endParaRPr lang="en-US" sz="1100" dirty="0"/>
           </a:p>

</xml_diff>

<commit_message>
docs: split the 5-minute demo evenly across the six presenters
Each member now has about 49 seconds. Security moves to Nemal and the
operations close to Charith, with hand-overs updated in the script and
speaker notes.

Co-Authored-By: Claude Sonnet 5.5 <noreply@anthropic.com>
</commit_message>
<xml_diff>
--- a/deliverables/REOAGMS-Team-Presentation.pptx
+++ b/deliverables/REOAGMS-Team-Presentation.pptx
@@ -511,7 +511,7 @@
           <a:p>
             <a:r>
               <a:rPr lang="en-US" dirty="0"/>
-              <a:t>Charith (0:00–0:10): Good morning. We are presenting REOAGMS, a platform that monitors and maintains renewable energy assets in real time.</a:t>
+              <a:t>Charith (0:00–0:08): Good morning. We are presenting REOAGMS, a platform that monitors and maintains renewable energy assets in real time.</a:t>
             </a:r>
             <a:endParaRPr lang="en-US" dirty="0"/>
           </a:p>
@@ -599,7 +599,7 @@
           <a:p>
             <a:r>
               <a:rPr lang="en-US" dirty="0"/>
-              <a:t>All members (4:50–5:00): Thank you. We are happy to take your questions.</a:t>
+              <a:t>All members (4:54–5:00): Thank you. We are happy to take your questions.</a:t>
             </a:r>
             <a:endParaRPr lang="en-US" dirty="0"/>
           </a:p>
@@ -687,7 +687,7 @@
           <a:p>
             <a:r>
               <a:rPr lang="en-US" dirty="0"/>
-              <a:t>Charith (0:10–0:45): REOAGMS is six Spring Boot microservices behind one API gateway, connected by RabbitMQ events, each with its own PostgreSQL database. I sign in as the administrator; the gateway validates my token and role. This is the control room: live generation, open alerts, device health and an hourly energy curve. Nemal will show where this data comes from.</a:t>
+              <a:t>Charith (0:08–0:33): REOAGMS is six Spring Boot microservices behind one API gateway, connected by RabbitMQ events, each with its own PostgreSQL database. I sign in as the administrator, and this is the control room with live data. Nemal will show where it comes from.</a:t>
             </a:r>
             <a:endParaRPr lang="en-US" dirty="0"/>
           </a:p>
@@ -775,7 +775,7 @@
           <a:p>
             <a:r>
               <a:rPr lang="en-US" dirty="0"/>
-              <a:t>Nemal (0:45–1:15): Thank you, Charith. The Asset Service owns the registry: five facilities, eleven assets and thirty-two sensors across solar, wind, hydro, battery and tidal. Lists are searched and paged on the server, and every form is validated, so a blank name is rejected. Only administrators and managers can change data. Every other service refers to these assets by ID. Govindu will show them producing live data.</a:t>
+              <a:t>Nemal (0:33–1:00): Thank you, Charith. The Asset Service owns the registry: five facilities, eleven assets and thirty-two sensors. Lists are searched and paged on the server, and every form is validated, so a blank name is rejected. Govindu will show these assets producing live data.</a:t>
             </a:r>
             <a:endParaRPr lang="en-US" dirty="0"/>
           </a:p>
@@ -863,7 +863,7 @@
           <a:p>
             <a:r>
               <a:rPr lang="en-US" dirty="0"/>
-              <a:t>Govindu (1:15–2:00): Thanks, Nemal. The Monitoring Service receives a reading from every sensor and checks it against our alert rules. This tile is a live sensor and the dashed line is its threshold. The simulator has just injected a fault, and here is the alert, instantly. One alert is stored, one event goes to RabbitMQ, and the browser is updated over WebSocket. That same event is now reaching Thurunu.</a:t>
+              <a:t>Govindu (1:00–1:49): Thanks, Nemal. The Monitoring Service receives a reading from every sensor and checks it against our alert rules. This tile is a live sensor and the dashed line is its threshold. The simulator has just injected a fault, and here is the alert, instantly. One alert is stored, one event goes to RabbitMQ, and the browser is updated over WebSocket. That same event is now reaching Thurunu.</a:t>
             </a:r>
             <a:endParaRPr lang="en-US" dirty="0"/>
           </a:p>
@@ -951,7 +951,7 @@
           <a:p>
             <a:r>
               <a:rPr lang="en-US" dirty="0"/>
-              <a:t>Thurunu (2:00–2:35): Yes. The Maintenance Service received the same event and, because the severity is high, it opened a corrective work order by itself. Here it is on the board. I assign a technician, start the work and complete it. Each step is its own endpoint, and the finished job is saved to the maintenance history. Yasiru will show how people are informed.</a:t>
+              <a:t>Thurunu (1:49–2:38): Yes. The Maintenance Service received the same event and, because the severity is high, it opened a corrective work order by itself. Here it is on the board. I assign a technician, start the work and complete it. Each step is its own endpoint, and the finished job is saved to the maintenance history. Yasiru will show how people are informed.</a:t>
             </a:r>
             <a:endParaRPr lang="en-US" dirty="0"/>
           </a:p>
@@ -1039,7 +1039,7 @@
           <a:p>
             <a:r>
               <a:rPr lang="en-US" dirty="0"/>
-              <a:t>Yasiru (2:35–3:05): The Notification Service read the same alert from its own RabbitMQ queue. In this history, the in-app push was delivered instantly, and every email attempt is stored with its status, retry count and reason. A scheduler retries up to three times, I can retry any message here, and failing messages go to a dead-letter queue, so nothing is lost. Sachinthana will turn all this into reports.</a:t>
+              <a:t>Yasiru (2:38–3:27): The Notification Service read the same alert from its own RabbitMQ queue. In this history, the in-app push was delivered instantly, and every email attempt is stored with its status, retry count and reason. A scheduler retries up to three times, I can retry any message here, and failing messages go to a dead-letter queue, so nothing is lost. Sachinthana will turn all this into reports.</a:t>
             </a:r>
             <a:endParaRPr lang="en-US" dirty="0"/>
           </a:p>
@@ -1127,7 +1127,7 @@
           <a:p>
             <a:r>
               <a:rPr lang="en-US" dirty="0"/>
-              <a:t>Sachinthana (3:05–3:45): The Analytics Service calls the other services over REST and never touches their databases. For this facility it integrates average power into kilowatt-hours for each hour, and calculates availability, efficiency and capacity factor. I generate an energy report for the last day and export it as CSV for management. Executives see all of this read-only. Charith will close with security.</a:t>
+              <a:t>Sachinthana (3:27–4:16): The Analytics Service calls the other services over REST and never touches their databases. For this facility it integrates average power into kilowatt-hours for each hour, and calculates availability, efficiency and capacity factor. I generate an energy report for the last day and export it as CSV for management. Nemal will show who is allowed to see it.</a:t>
             </a:r>
             <a:endParaRPr lang="en-US" dirty="0"/>
           </a:p>
@@ -1215,7 +1215,7 @@
           <a:p>
             <a:r>
               <a:rPr lang="en-US" dirty="0"/>
-              <a:t>Charith (3:45–4:15): Security is enforced at the gateway. Five roles carry different rights. I sign in as the executive: there are no action buttons, and the API itself answers 403 for any write. Every login and user change is recorded in the audit log. Quality is built in as well, with sixty test methods across the services.</a:t>
+              <a:t>Nemal (4:16–4:38): Access is enforced at the gateway, and five roles carry different rights. I sign in as the executive: there are no action buttons, and the API itself refuses any write. Charith will close.</a:t>
             </a:r>
             <a:endParaRPr lang="en-US" dirty="0"/>
           </a:p>
@@ -1303,7 +1303,7 @@
           <a:p>
             <a:r>
               <a:rPr lang="en-US" dirty="0"/>
-              <a:t>Charith (4:15–4:50): Operations are visible in Grafana, where Prometheus scrapes all seven services and shows platform health. Behind the demo are sixty test methods, validation and error handling in every service, and a versioned event contract that keeps the services compatible. The whole system starts with one docker compose command.</a:t>
+              <a:t>Charith (4:38–4:54): Grafana shows platform health from Prometheus across all seven services. Sixty tests protect the services, and one docker compose command starts everything.</a:t>
             </a:r>
             <a:endParaRPr lang="en-US" dirty="0"/>
           </a:p>
@@ -2202,7 +2202,7 @@
                 <a:ea typeface="Segoe UI" pitchFamily="34" charset="-122"/>
                 <a:cs typeface="Segoe UI" pitchFamily="34" charset="-120"/>
               </a:rPr>
-              <a:t>02  ·  0:10–0:45</a:t>
+              <a:t>02  ·  0:08–0:33</a:t>
             </a:r>
             <a:endParaRPr lang="en-US" sz="900" dirty="0"/>
           </a:p>
@@ -3298,7 +3298,7 @@
                 <a:ea typeface="Segoe UI" pitchFamily="34" charset="-122"/>
                 <a:cs typeface="Segoe UI" pitchFamily="34" charset="-120"/>
               </a:rPr>
-              <a:t>03  ·  0:45–1:15</a:t>
+              <a:t>03  ·  0:33–1:00</a:t>
             </a:r>
             <a:endParaRPr lang="en-US" sz="900" dirty="0"/>
           </a:p>
@@ -4262,7 +4262,7 @@
                 <a:ea typeface="Segoe UI" pitchFamily="34" charset="-122"/>
                 <a:cs typeface="Segoe UI" pitchFamily="34" charset="-120"/>
               </a:rPr>
-              <a:t>04  ·  1:15–2:00</a:t>
+              <a:t>04  ·  1:00–1:49</a:t>
             </a:r>
             <a:endParaRPr lang="en-US" sz="900" dirty="0"/>
           </a:p>
@@ -5370,7 +5370,7 @@
                 <a:ea typeface="Segoe UI" pitchFamily="34" charset="-122"/>
                 <a:cs typeface="Segoe UI" pitchFamily="34" charset="-120"/>
               </a:rPr>
-              <a:t>05  ·  2:00–2:35</a:t>
+              <a:t>05  ·  1:49–2:38</a:t>
             </a:r>
             <a:endParaRPr lang="en-US" sz="900" dirty="0"/>
           </a:p>
@@ -6478,7 +6478,7 @@
                 <a:ea typeface="Segoe UI" pitchFamily="34" charset="-122"/>
                 <a:cs typeface="Segoe UI" pitchFamily="34" charset="-120"/>
               </a:rPr>
-              <a:t>06  ·  2:35–3:05</a:t>
+              <a:t>06  ·  2:38–3:27</a:t>
             </a:r>
             <a:endParaRPr lang="en-US" sz="900" dirty="0"/>
           </a:p>
@@ -7586,7 +7586,7 @@
                 <a:ea typeface="Segoe UI" pitchFamily="34" charset="-122"/>
                 <a:cs typeface="Segoe UI" pitchFamily="34" charset="-120"/>
               </a:rPr>
-              <a:t>07  ·  3:05–3:45</a:t>
+              <a:t>07  ·  3:27–4:16</a:t>
             </a:r>
             <a:endParaRPr lang="en-US" sz="900" dirty="0"/>
           </a:p>
@@ -8577,7 +8577,7 @@
                 <a:ea typeface="Segoe UI Semibold" pitchFamily="34" charset="-122"/>
                 <a:cs typeface="Segoe UI Semibold" pitchFamily="34" charset="-120"/>
               </a:rPr>
-              <a:t>08 · CHARITH · SECURITY</a:t>
+              <a:t>08 · NEMAL · SECURITY</a:t>
             </a:r>
             <a:endParaRPr lang="en-US" sz="1100" dirty="0"/>
           </a:p>
@@ -8694,7 +8694,7 @@
                 <a:ea typeface="Segoe UI" pitchFamily="34" charset="-122"/>
                 <a:cs typeface="Segoe UI" pitchFamily="34" charset="-120"/>
               </a:rPr>
-              <a:t>08  ·  3:45–4:15</a:t>
+              <a:t>08  ·  4:16–4:38</a:t>
             </a:r>
             <a:endParaRPr lang="en-US" sz="900" dirty="0"/>
           </a:p>
@@ -9487,7 +9487,7 @@
                 <a:ea typeface="Segoe UI" pitchFamily="34" charset="-122"/>
                 <a:cs typeface="Segoe UI" pitchFamily="34" charset="-120"/>
               </a:rPr>
-              <a:t>09  ·  4:15–4:50</a:t>
+              <a:t>09  ·  4:38–4:54</a:t>
             </a:r>
             <a:endParaRPr lang="en-US" sz="900" dirty="0"/>
           </a:p>

</xml_diff>

<commit_message>
docs: add Group 9 member names and registration numbers to the title slide
Co-Authored-By: Claude Sonnet 5.5 <noreply@anthropic.com>
</commit_message>
<xml_diff>
--- a/deliverables/REOAGMS-Team-Presentation.pptx
+++ b/deliverables/REOAGMS-Team-Presentation.pptx
@@ -1775,7 +1775,7 @@
                 <a:ea typeface="Segoe UI Semibold" pitchFamily="34" charset="-122"/>
                 <a:cs typeface="Segoe UI Semibold" pitchFamily="34" charset="-120"/>
               </a:rPr>
-              <a:t>EC8208  ·  SOFTWARE ARCHITECTURE</a:t>
+              <a:t>GROUP 9  ·  EC8208  ·  SOFTWARE ARCHITECTURE</a:t>
             </a:r>
             <a:endParaRPr lang="en-US" sz="1200" dirty="0"/>
           </a:p>
@@ -1867,8 +1867,8 @@
         </p:nvSpPr>
         <p:spPr>
           <a:xfrm>
-            <a:off x="640080" y="3977640"/>
-            <a:ext cx="7863840" cy="320040"/>
+            <a:off x="640080" y="3200400"/>
+            <a:ext cx="3017520" cy="292608"/>
           </a:xfrm>
           <a:prstGeom prst="rect">
             <a:avLst/>
@@ -1884,17 +1884,31 @@
               <a:buNone/>
             </a:pPr>
             <a:r>
-              <a:rPr lang="en-US" sz="1400" dirty="0">
+              <a:rPr lang="en-US" sz="1300" dirty="0">
+                <a:solidFill>
+                  <a:srgbClr val="22D3EE"/>
+                </a:solidFill>
+                <a:latin typeface="Segoe UI" pitchFamily="34" charset="0"/>
+                <a:ea typeface="Segoe UI" pitchFamily="34" charset="-122"/>
+                <a:cs typeface="Segoe UI" pitchFamily="34" charset="-120"/>
+              </a:rPr>
+              <a:t>EG/2021/4707   </a:t>
+            </a:r>
+            <a:pPr indent="0" marL="0">
+              <a:buNone/>
+            </a:pPr>
+            <a:r>
+              <a:rPr lang="en-US" sz="1300" b="1" dirty="0">
                 <a:solidFill>
                   <a:srgbClr val="F1F5FB"/>
                 </a:solidFill>
-                <a:latin typeface="Segoe UI Semibold" pitchFamily="34" charset="0"/>
-                <a:ea typeface="Segoe UI Semibold" pitchFamily="34" charset="-122"/>
-                <a:cs typeface="Segoe UI Semibold" pitchFamily="34" charset="-120"/>
-              </a:rPr>
-              <a:t>Charith  ·  Nemal  ·  Govindu  ·  Thurunu  ·  Yasiru  ·  Sachinthana</a:t>
-            </a:r>
-            <a:endParaRPr lang="en-US" sz="1400" dirty="0"/>
+                <a:latin typeface="Segoe UI" pitchFamily="34" charset="0"/>
+                <a:ea typeface="Segoe UI" pitchFamily="34" charset="-122"/>
+                <a:cs typeface="Segoe UI" pitchFamily="34" charset="-120"/>
+              </a:rPr>
+              <a:t>Perera G C M</a:t>
+            </a:r>
+            <a:endParaRPr lang="en-US" sz="1300" dirty="0"/>
           </a:p>
         </p:txBody>
       </p:sp>
@@ -1906,7 +1920,272 @@
         </p:nvSpPr>
         <p:spPr>
           <a:xfrm>
-            <a:off x="640080" y="4343400"/>
+            <a:off x="640080" y="3547872"/>
+            <a:ext cx="3017520" cy="292608"/>
+          </a:xfrm>
+          <a:prstGeom prst="rect">
+            <a:avLst/>
+          </a:prstGeom>
+          <a:noFill/>
+          <a:ln/>
+        </p:spPr>
+        <p:txBody>
+          <a:bodyPr wrap="square" lIns="0" tIns="0" rIns="0" bIns="0" rtlCol="0" anchor="ctr"/>
+          <a:lstStyle/>
+          <a:p>
+            <a:pPr indent="0" marL="0">
+              <a:buNone/>
+            </a:pPr>
+            <a:r>
+              <a:rPr lang="en-US" sz="1300" dirty="0">
+                <a:solidFill>
+                  <a:srgbClr val="22D3EE"/>
+                </a:solidFill>
+                <a:latin typeface="Segoe UI" pitchFamily="34" charset="0"/>
+                <a:ea typeface="Segoe UI" pitchFamily="34" charset="-122"/>
+                <a:cs typeface="Segoe UI" pitchFamily="34" charset="-120"/>
+              </a:rPr>
+              <a:t>EG/2021/4620   </a:t>
+            </a:r>
+            <a:pPr indent="0" marL="0">
+              <a:buNone/>
+            </a:pPr>
+            <a:r>
+              <a:rPr lang="en-US" sz="1300" b="1" dirty="0">
+                <a:solidFill>
+                  <a:srgbClr val="F1F5FB"/>
+                </a:solidFill>
+                <a:latin typeface="Segoe UI" pitchFamily="34" charset="0"/>
+                <a:ea typeface="Segoe UI" pitchFamily="34" charset="-122"/>
+                <a:cs typeface="Segoe UI" pitchFamily="34" charset="-120"/>
+              </a:rPr>
+              <a:t>Kularathne MDYB</a:t>
+            </a:r>
+            <a:endParaRPr lang="en-US" sz="1300" dirty="0"/>
+          </a:p>
+        </p:txBody>
+      </p:sp>
+      <p:sp>
+        <p:nvSpPr>
+          <p:cNvPr id="11" name="Text 8"/>
+          <p:cNvSpPr txBox="1"/>
+          <p:nvPr/>
+        </p:nvSpPr>
+        <p:spPr>
+          <a:xfrm>
+            <a:off x="640080" y="3895344"/>
+            <a:ext cx="3017520" cy="292608"/>
+          </a:xfrm>
+          <a:prstGeom prst="rect">
+            <a:avLst/>
+          </a:prstGeom>
+          <a:noFill/>
+          <a:ln/>
+        </p:spPr>
+        <p:txBody>
+          <a:bodyPr wrap="square" lIns="0" tIns="0" rIns="0" bIns="0" rtlCol="0" anchor="ctr"/>
+          <a:lstStyle/>
+          <a:p>
+            <a:pPr indent="0" marL="0">
+              <a:buNone/>
+            </a:pPr>
+            <a:r>
+              <a:rPr lang="en-US" sz="1300" dirty="0">
+                <a:solidFill>
+                  <a:srgbClr val="22D3EE"/>
+                </a:solidFill>
+                <a:latin typeface="Segoe UI" pitchFamily="34" charset="0"/>
+                <a:ea typeface="Segoe UI" pitchFamily="34" charset="-122"/>
+                <a:cs typeface="Segoe UI" pitchFamily="34" charset="-120"/>
+              </a:rPr>
+              <a:t>EG/2021/4710   </a:t>
+            </a:r>
+            <a:pPr indent="0" marL="0">
+              <a:buNone/>
+            </a:pPr>
+            <a:r>
+              <a:rPr lang="en-US" sz="1300" b="1" dirty="0">
+                <a:solidFill>
+                  <a:srgbClr val="F1F5FB"/>
+                </a:solidFill>
+                <a:latin typeface="Segoe UI" pitchFamily="34" charset="0"/>
+                <a:ea typeface="Segoe UI" pitchFamily="34" charset="-122"/>
+                <a:cs typeface="Segoe UI" pitchFamily="34" charset="-120"/>
+              </a:rPr>
+              <a:t>Perera K P D N</a:t>
+            </a:r>
+            <a:endParaRPr lang="en-US" sz="1300" dirty="0"/>
+          </a:p>
+        </p:txBody>
+      </p:sp>
+      <p:sp>
+        <p:nvSpPr>
+          <p:cNvPr id="12" name="Text 9"/>
+          <p:cNvSpPr txBox="1"/>
+          <p:nvPr/>
+        </p:nvSpPr>
+        <p:spPr>
+          <a:xfrm>
+            <a:off x="3749040" y="3200400"/>
+            <a:ext cx="3017520" cy="292608"/>
+          </a:xfrm>
+          <a:prstGeom prst="rect">
+            <a:avLst/>
+          </a:prstGeom>
+          <a:noFill/>
+          <a:ln/>
+        </p:spPr>
+        <p:txBody>
+          <a:bodyPr wrap="square" lIns="0" tIns="0" rIns="0" bIns="0" rtlCol="0" anchor="ctr"/>
+          <a:lstStyle/>
+          <a:p>
+            <a:pPr indent="0" marL="0">
+              <a:buNone/>
+            </a:pPr>
+            <a:r>
+              <a:rPr lang="en-US" sz="1300" dirty="0">
+                <a:solidFill>
+                  <a:srgbClr val="22D3EE"/>
+                </a:solidFill>
+                <a:latin typeface="Segoe UI" pitchFamily="34" charset="0"/>
+                <a:ea typeface="Segoe UI" pitchFamily="34" charset="-122"/>
+                <a:cs typeface="Segoe UI" pitchFamily="34" charset="-120"/>
+              </a:rPr>
+              <a:t>EG/2021/4828   </a:t>
+            </a:r>
+            <a:pPr indent="0" marL="0">
+              <a:buNone/>
+            </a:pPr>
+            <a:r>
+              <a:rPr lang="en-US" sz="1300" b="1" dirty="0">
+                <a:solidFill>
+                  <a:srgbClr val="F1F5FB"/>
+                </a:solidFill>
+                <a:latin typeface="Segoe UI" pitchFamily="34" charset="0"/>
+                <a:ea typeface="Segoe UI" pitchFamily="34" charset="-122"/>
+                <a:cs typeface="Segoe UI" pitchFamily="34" charset="-120"/>
+              </a:rPr>
+              <a:t>Thejana BPGL</a:t>
+            </a:r>
+            <a:endParaRPr lang="en-US" sz="1300" dirty="0"/>
+          </a:p>
+        </p:txBody>
+      </p:sp>
+      <p:sp>
+        <p:nvSpPr>
+          <p:cNvPr id="13" name="Text 10"/>
+          <p:cNvSpPr txBox="1"/>
+          <p:nvPr/>
+        </p:nvSpPr>
+        <p:spPr>
+          <a:xfrm>
+            <a:off x="3749040" y="3547872"/>
+            <a:ext cx="3017520" cy="292608"/>
+          </a:xfrm>
+          <a:prstGeom prst="rect">
+            <a:avLst/>
+          </a:prstGeom>
+          <a:noFill/>
+          <a:ln/>
+        </p:spPr>
+        <p:txBody>
+          <a:bodyPr wrap="square" lIns="0" tIns="0" rIns="0" bIns="0" rtlCol="0" anchor="ctr"/>
+          <a:lstStyle/>
+          <a:p>
+            <a:pPr indent="0" marL="0">
+              <a:buNone/>
+            </a:pPr>
+            <a:r>
+              <a:rPr lang="en-US" sz="1300" dirty="0">
+                <a:solidFill>
+                  <a:srgbClr val="22D3EE"/>
+                </a:solidFill>
+                <a:latin typeface="Segoe UI" pitchFamily="34" charset="0"/>
+                <a:ea typeface="Segoe UI" pitchFamily="34" charset="-122"/>
+                <a:cs typeface="Segoe UI" pitchFamily="34" charset="-120"/>
+              </a:rPr>
+              <a:t>EG/2021/4701   </a:t>
+            </a:r>
+            <a:pPr indent="0" marL="0">
+              <a:buNone/>
+            </a:pPr>
+            <a:r>
+              <a:rPr lang="en-US" sz="1300" b="1" dirty="0">
+                <a:solidFill>
+                  <a:srgbClr val="F1F5FB"/>
+                </a:solidFill>
+                <a:latin typeface="Segoe UI" pitchFamily="34" charset="0"/>
+                <a:ea typeface="Segoe UI" pitchFamily="34" charset="-122"/>
+                <a:cs typeface="Segoe UI" pitchFamily="34" charset="-120"/>
+              </a:rPr>
+              <a:t>Pabasara PMGT</a:t>
+            </a:r>
+            <a:endParaRPr lang="en-US" sz="1300" dirty="0"/>
+          </a:p>
+        </p:txBody>
+      </p:sp>
+      <p:sp>
+        <p:nvSpPr>
+          <p:cNvPr id="14" name="Text 11"/>
+          <p:cNvSpPr txBox="1"/>
+          <p:nvPr/>
+        </p:nvSpPr>
+        <p:spPr>
+          <a:xfrm>
+            <a:off x="3749040" y="3895344"/>
+            <a:ext cx="3017520" cy="292608"/>
+          </a:xfrm>
+          <a:prstGeom prst="rect">
+            <a:avLst/>
+          </a:prstGeom>
+          <a:noFill/>
+          <a:ln/>
+        </p:spPr>
+        <p:txBody>
+          <a:bodyPr wrap="square" lIns="0" tIns="0" rIns="0" bIns="0" rtlCol="0" anchor="ctr"/>
+          <a:lstStyle/>
+          <a:p>
+            <a:pPr indent="0" marL="0">
+              <a:buNone/>
+            </a:pPr>
+            <a:r>
+              <a:rPr lang="en-US" sz="1300" dirty="0">
+                <a:solidFill>
+                  <a:srgbClr val="22D3EE"/>
+                </a:solidFill>
+                <a:latin typeface="Segoe UI" pitchFamily="34" charset="0"/>
+                <a:ea typeface="Segoe UI" pitchFamily="34" charset="-122"/>
+                <a:cs typeface="Segoe UI" pitchFamily="34" charset="-120"/>
+              </a:rPr>
+              <a:t>EG/2021/4770   </a:t>
+            </a:r>
+            <a:pPr indent="0" marL="0">
+              <a:buNone/>
+            </a:pPr>
+            <a:r>
+              <a:rPr lang="en-US" sz="1300" b="1" dirty="0">
+                <a:solidFill>
+                  <a:srgbClr val="F1F5FB"/>
+                </a:solidFill>
+                <a:latin typeface="Segoe UI" pitchFamily="34" charset="0"/>
+                <a:ea typeface="Segoe UI" pitchFamily="34" charset="-122"/>
+                <a:cs typeface="Segoe UI" pitchFamily="34" charset="-120"/>
+              </a:rPr>
+              <a:t>Sachinthana K AD</a:t>
+            </a:r>
+            <a:endParaRPr lang="en-US" sz="1300" dirty="0"/>
+          </a:p>
+        </p:txBody>
+      </p:sp>
+      <p:sp>
+        <p:nvSpPr>
+          <p:cNvPr id="15" name="Text 12"/>
+          <p:cNvSpPr txBox="1"/>
+          <p:nvPr/>
+        </p:nvSpPr>
+        <p:spPr>
+          <a:xfrm>
+            <a:off x="640080" y="4434840"/>
             <a:ext cx="7863840" cy="274320"/>
           </a:xfrm>
           <a:prstGeom prst="rect">

</xml_diff>